<commit_message>
readme miou rework and fonts presentation
</commit_message>
<xml_diff>
--- a/unet_inference.pptx
+++ b/unet_inference.pptx
@@ -625,7 +625,7 @@
         <p:cNvPr id="1" name="Shape 505">
           <a:extLst>
             <a:ext uri="{FF2B5EF4-FFF2-40B4-BE49-F238E27FC236}">
-              <a16:creationId xmlns:a16="http://schemas.microsoft.com/office/drawing/2014/main" xmlns="" id="{68B89A22-7252-9D3E-55DF-11950A57FFC2}"/>
+              <a16:creationId xmlns="" xmlns:a16="http://schemas.microsoft.com/office/drawing/2014/main" id="{68B89A22-7252-9D3E-55DF-11950A57FFC2}"/>
             </a:ext>
           </a:extLst>
         </p:cNvPr>
@@ -645,7 +645,7 @@
           <p:cNvPr id="506" name="Google Shape;506;g1ec3e76e843_0_431:notes">
             <a:extLst>
               <a:ext uri="{FF2B5EF4-FFF2-40B4-BE49-F238E27FC236}">
-                <a16:creationId xmlns:a16="http://schemas.microsoft.com/office/drawing/2014/main" xmlns="" id="{446C6FAF-FEA0-FF3A-32BF-B5973FCA4D67}"/>
+                <a16:creationId xmlns="" xmlns:a16="http://schemas.microsoft.com/office/drawing/2014/main" id="{446C6FAF-FEA0-FF3A-32BF-B5973FCA4D67}"/>
               </a:ext>
             </a:extLst>
           </p:cNvPr>
@@ -692,7 +692,7 @@
           <p:cNvPr id="507" name="Google Shape;507;g1ec3e76e843_0_431:notes">
             <a:extLst>
               <a:ext uri="{FF2B5EF4-FFF2-40B4-BE49-F238E27FC236}">
-                <a16:creationId xmlns:a16="http://schemas.microsoft.com/office/drawing/2014/main" xmlns="" id="{3716BF81-477D-0AF8-9019-7D40FF93FC9F}"/>
+                <a16:creationId xmlns="" xmlns:a16="http://schemas.microsoft.com/office/drawing/2014/main" id="{3716BF81-477D-0AF8-9019-7D40FF93FC9F}"/>
               </a:ext>
             </a:extLst>
           </p:cNvPr>
@@ -1188,7 +1188,7 @@
         <p:cNvPr id="1" name="Shape 505">
           <a:extLst>
             <a:ext uri="{FF2B5EF4-FFF2-40B4-BE49-F238E27FC236}">
-              <a16:creationId xmlns:a16="http://schemas.microsoft.com/office/drawing/2014/main" xmlns="" id="{68B89A22-7252-9D3E-55DF-11950A57FFC2}"/>
+              <a16:creationId xmlns="" xmlns:a16="http://schemas.microsoft.com/office/drawing/2014/main" id="{68B89A22-7252-9D3E-55DF-11950A57FFC2}"/>
             </a:ext>
           </a:extLst>
         </p:cNvPr>
@@ -1208,7 +1208,7 @@
           <p:cNvPr id="506" name="Google Shape;506;g1ec3e76e843_0_431:notes">
             <a:extLst>
               <a:ext uri="{FF2B5EF4-FFF2-40B4-BE49-F238E27FC236}">
-                <a16:creationId xmlns:a16="http://schemas.microsoft.com/office/drawing/2014/main" xmlns="" id="{446C6FAF-FEA0-FF3A-32BF-B5973FCA4D67}"/>
+                <a16:creationId xmlns="" xmlns:a16="http://schemas.microsoft.com/office/drawing/2014/main" id="{446C6FAF-FEA0-FF3A-32BF-B5973FCA4D67}"/>
               </a:ext>
             </a:extLst>
           </p:cNvPr>
@@ -1255,7 +1255,7 @@
           <p:cNvPr id="507" name="Google Shape;507;g1ec3e76e843_0_431:notes">
             <a:extLst>
               <a:ext uri="{FF2B5EF4-FFF2-40B4-BE49-F238E27FC236}">
-                <a16:creationId xmlns:a16="http://schemas.microsoft.com/office/drawing/2014/main" xmlns="" id="{3716BF81-477D-0AF8-9019-7D40FF93FC9F}"/>
+                <a16:creationId xmlns="" xmlns:a16="http://schemas.microsoft.com/office/drawing/2014/main" id="{3716BF81-477D-0AF8-9019-7D40FF93FC9F}"/>
               </a:ext>
             </a:extLst>
           </p:cNvPr>
@@ -1533,7 +1533,7 @@
         <p:cNvPr id="1" name="Shape 505">
           <a:extLst>
             <a:ext uri="{FF2B5EF4-FFF2-40B4-BE49-F238E27FC236}">
-              <a16:creationId xmlns:a16="http://schemas.microsoft.com/office/drawing/2014/main" xmlns="" id="{68B89A22-7252-9D3E-55DF-11950A57FFC2}"/>
+              <a16:creationId xmlns="" xmlns:a16="http://schemas.microsoft.com/office/drawing/2014/main" id="{68B89A22-7252-9D3E-55DF-11950A57FFC2}"/>
             </a:ext>
           </a:extLst>
         </p:cNvPr>
@@ -1553,7 +1553,7 @@
           <p:cNvPr id="506" name="Google Shape;506;g1ec3e76e843_0_431:notes">
             <a:extLst>
               <a:ext uri="{FF2B5EF4-FFF2-40B4-BE49-F238E27FC236}">
-                <a16:creationId xmlns:a16="http://schemas.microsoft.com/office/drawing/2014/main" xmlns="" id="{446C6FAF-FEA0-FF3A-32BF-B5973FCA4D67}"/>
+                <a16:creationId xmlns="" xmlns:a16="http://schemas.microsoft.com/office/drawing/2014/main" id="{446C6FAF-FEA0-FF3A-32BF-B5973FCA4D67}"/>
               </a:ext>
             </a:extLst>
           </p:cNvPr>
@@ -1600,7 +1600,7 @@
           <p:cNvPr id="507" name="Google Shape;507;g1ec3e76e843_0_431:notes">
             <a:extLst>
               <a:ext uri="{FF2B5EF4-FFF2-40B4-BE49-F238E27FC236}">
-                <a16:creationId xmlns:a16="http://schemas.microsoft.com/office/drawing/2014/main" xmlns="" id="{3716BF81-477D-0AF8-9019-7D40FF93FC9F}"/>
+                <a16:creationId xmlns="" xmlns:a16="http://schemas.microsoft.com/office/drawing/2014/main" id="{3716BF81-477D-0AF8-9019-7D40FF93FC9F}"/>
               </a:ext>
             </a:extLst>
           </p:cNvPr>
@@ -1660,7 +1660,7 @@
         <p:cNvPr id="1" name="Shape 505">
           <a:extLst>
             <a:ext uri="{FF2B5EF4-FFF2-40B4-BE49-F238E27FC236}">
-              <a16:creationId xmlns:a16="http://schemas.microsoft.com/office/drawing/2014/main" xmlns="" id="{68B89A22-7252-9D3E-55DF-11950A57FFC2}"/>
+              <a16:creationId xmlns="" xmlns:a16="http://schemas.microsoft.com/office/drawing/2014/main" id="{68B89A22-7252-9D3E-55DF-11950A57FFC2}"/>
             </a:ext>
           </a:extLst>
         </p:cNvPr>
@@ -1680,7 +1680,7 @@
           <p:cNvPr id="506" name="Google Shape;506;g1ec3e76e843_0_431:notes">
             <a:extLst>
               <a:ext uri="{FF2B5EF4-FFF2-40B4-BE49-F238E27FC236}">
-                <a16:creationId xmlns:a16="http://schemas.microsoft.com/office/drawing/2014/main" xmlns="" id="{446C6FAF-FEA0-FF3A-32BF-B5973FCA4D67}"/>
+                <a16:creationId xmlns="" xmlns:a16="http://schemas.microsoft.com/office/drawing/2014/main" id="{446C6FAF-FEA0-FF3A-32BF-B5973FCA4D67}"/>
               </a:ext>
             </a:extLst>
           </p:cNvPr>
@@ -1727,7 +1727,7 @@
           <p:cNvPr id="507" name="Google Shape;507;g1ec3e76e843_0_431:notes">
             <a:extLst>
               <a:ext uri="{FF2B5EF4-FFF2-40B4-BE49-F238E27FC236}">
-                <a16:creationId xmlns:a16="http://schemas.microsoft.com/office/drawing/2014/main" xmlns="" id="{3716BF81-477D-0AF8-9019-7D40FF93FC9F}"/>
+                <a16:creationId xmlns="" xmlns:a16="http://schemas.microsoft.com/office/drawing/2014/main" id="{3716BF81-477D-0AF8-9019-7D40FF93FC9F}"/>
               </a:ext>
             </a:extLst>
           </p:cNvPr>
@@ -2114,7 +2114,7 @@
         <p:cNvPr id="1" name="Shape 505">
           <a:extLst>
             <a:ext uri="{FF2B5EF4-FFF2-40B4-BE49-F238E27FC236}">
-              <a16:creationId xmlns:a16="http://schemas.microsoft.com/office/drawing/2014/main" xmlns="" id="{68B89A22-7252-9D3E-55DF-11950A57FFC2}"/>
+              <a16:creationId xmlns="" xmlns:a16="http://schemas.microsoft.com/office/drawing/2014/main" id="{68B89A22-7252-9D3E-55DF-11950A57FFC2}"/>
             </a:ext>
           </a:extLst>
         </p:cNvPr>
@@ -2134,7 +2134,7 @@
           <p:cNvPr id="506" name="Google Shape;506;g1ec3e76e843_0_431:notes">
             <a:extLst>
               <a:ext uri="{FF2B5EF4-FFF2-40B4-BE49-F238E27FC236}">
-                <a16:creationId xmlns:a16="http://schemas.microsoft.com/office/drawing/2014/main" xmlns="" id="{446C6FAF-FEA0-FF3A-32BF-B5973FCA4D67}"/>
+                <a16:creationId xmlns="" xmlns:a16="http://schemas.microsoft.com/office/drawing/2014/main" id="{446C6FAF-FEA0-FF3A-32BF-B5973FCA4D67}"/>
               </a:ext>
             </a:extLst>
           </p:cNvPr>
@@ -2181,7 +2181,7 @@
           <p:cNvPr id="507" name="Google Shape;507;g1ec3e76e843_0_431:notes">
             <a:extLst>
               <a:ext uri="{FF2B5EF4-FFF2-40B4-BE49-F238E27FC236}">
-                <a16:creationId xmlns:a16="http://schemas.microsoft.com/office/drawing/2014/main" xmlns="" id="{3716BF81-477D-0AF8-9019-7D40FF93FC9F}"/>
+                <a16:creationId xmlns="" xmlns:a16="http://schemas.microsoft.com/office/drawing/2014/main" id="{3716BF81-477D-0AF8-9019-7D40FF93FC9F}"/>
               </a:ext>
             </a:extLst>
           </p:cNvPr>
@@ -2241,7 +2241,7 @@
         <p:cNvPr id="1" name="Shape 505">
           <a:extLst>
             <a:ext uri="{FF2B5EF4-FFF2-40B4-BE49-F238E27FC236}">
-              <a16:creationId xmlns:a16="http://schemas.microsoft.com/office/drawing/2014/main" xmlns="" id="{68B89A22-7252-9D3E-55DF-11950A57FFC2}"/>
+              <a16:creationId xmlns="" xmlns:a16="http://schemas.microsoft.com/office/drawing/2014/main" id="{68B89A22-7252-9D3E-55DF-11950A57FFC2}"/>
             </a:ext>
           </a:extLst>
         </p:cNvPr>
@@ -2261,7 +2261,7 @@
           <p:cNvPr id="506" name="Google Shape;506;g1ec3e76e843_0_431:notes">
             <a:extLst>
               <a:ext uri="{FF2B5EF4-FFF2-40B4-BE49-F238E27FC236}">
-                <a16:creationId xmlns:a16="http://schemas.microsoft.com/office/drawing/2014/main" xmlns="" id="{446C6FAF-FEA0-FF3A-32BF-B5973FCA4D67}"/>
+                <a16:creationId xmlns="" xmlns:a16="http://schemas.microsoft.com/office/drawing/2014/main" id="{446C6FAF-FEA0-FF3A-32BF-B5973FCA4D67}"/>
               </a:ext>
             </a:extLst>
           </p:cNvPr>
@@ -2308,7 +2308,7 @@
           <p:cNvPr id="507" name="Google Shape;507;g1ec3e76e843_0_431:notes">
             <a:extLst>
               <a:ext uri="{FF2B5EF4-FFF2-40B4-BE49-F238E27FC236}">
-                <a16:creationId xmlns:a16="http://schemas.microsoft.com/office/drawing/2014/main" xmlns="" id="{3716BF81-477D-0AF8-9019-7D40FF93FC9F}"/>
+                <a16:creationId xmlns="" xmlns:a16="http://schemas.microsoft.com/office/drawing/2014/main" id="{3716BF81-477D-0AF8-9019-7D40FF93FC9F}"/>
               </a:ext>
             </a:extLst>
           </p:cNvPr>
@@ -2368,7 +2368,7 @@
         <p:cNvPr id="1" name="Shape 505">
           <a:extLst>
             <a:ext uri="{FF2B5EF4-FFF2-40B4-BE49-F238E27FC236}">
-              <a16:creationId xmlns:a16="http://schemas.microsoft.com/office/drawing/2014/main" xmlns="" id="{68B89A22-7252-9D3E-55DF-11950A57FFC2}"/>
+              <a16:creationId xmlns="" xmlns:a16="http://schemas.microsoft.com/office/drawing/2014/main" id="{68B89A22-7252-9D3E-55DF-11950A57FFC2}"/>
             </a:ext>
           </a:extLst>
         </p:cNvPr>
@@ -2388,7 +2388,7 @@
           <p:cNvPr id="506" name="Google Shape;506;g1ec3e76e843_0_431:notes">
             <a:extLst>
               <a:ext uri="{FF2B5EF4-FFF2-40B4-BE49-F238E27FC236}">
-                <a16:creationId xmlns:a16="http://schemas.microsoft.com/office/drawing/2014/main" xmlns="" id="{446C6FAF-FEA0-FF3A-32BF-B5973FCA4D67}"/>
+                <a16:creationId xmlns="" xmlns:a16="http://schemas.microsoft.com/office/drawing/2014/main" id="{446C6FAF-FEA0-FF3A-32BF-B5973FCA4D67}"/>
               </a:ext>
             </a:extLst>
           </p:cNvPr>
@@ -2435,7 +2435,7 @@
           <p:cNvPr id="507" name="Google Shape;507;g1ec3e76e843_0_431:notes">
             <a:extLst>
               <a:ext uri="{FF2B5EF4-FFF2-40B4-BE49-F238E27FC236}">
-                <a16:creationId xmlns:a16="http://schemas.microsoft.com/office/drawing/2014/main" xmlns="" id="{3716BF81-477D-0AF8-9019-7D40FF93FC9F}"/>
+                <a16:creationId xmlns="" xmlns:a16="http://schemas.microsoft.com/office/drawing/2014/main" id="{3716BF81-477D-0AF8-9019-7D40FF93FC9F}"/>
               </a:ext>
             </a:extLst>
           </p:cNvPr>
@@ -2604,7 +2604,7 @@
         <p:cNvPr id="1" name="Shape 505">
           <a:extLst>
             <a:ext uri="{FF2B5EF4-FFF2-40B4-BE49-F238E27FC236}">
-              <a16:creationId xmlns:a16="http://schemas.microsoft.com/office/drawing/2014/main" xmlns="" id="{68B89A22-7252-9D3E-55DF-11950A57FFC2}"/>
+              <a16:creationId xmlns="" xmlns:a16="http://schemas.microsoft.com/office/drawing/2014/main" id="{68B89A22-7252-9D3E-55DF-11950A57FFC2}"/>
             </a:ext>
           </a:extLst>
         </p:cNvPr>
@@ -2624,7 +2624,7 @@
           <p:cNvPr id="506" name="Google Shape;506;g1ec3e76e843_0_431:notes">
             <a:extLst>
               <a:ext uri="{FF2B5EF4-FFF2-40B4-BE49-F238E27FC236}">
-                <a16:creationId xmlns:a16="http://schemas.microsoft.com/office/drawing/2014/main" xmlns="" id="{446C6FAF-FEA0-FF3A-32BF-B5973FCA4D67}"/>
+                <a16:creationId xmlns="" xmlns:a16="http://schemas.microsoft.com/office/drawing/2014/main" id="{446C6FAF-FEA0-FF3A-32BF-B5973FCA4D67}"/>
               </a:ext>
             </a:extLst>
           </p:cNvPr>
@@ -2671,7 +2671,7 @@
           <p:cNvPr id="507" name="Google Shape;507;g1ec3e76e843_0_431:notes">
             <a:extLst>
               <a:ext uri="{FF2B5EF4-FFF2-40B4-BE49-F238E27FC236}">
-                <a16:creationId xmlns:a16="http://schemas.microsoft.com/office/drawing/2014/main" xmlns="" id="{3716BF81-477D-0AF8-9019-7D40FF93FC9F}"/>
+                <a16:creationId xmlns="" xmlns:a16="http://schemas.microsoft.com/office/drawing/2014/main" id="{3716BF81-477D-0AF8-9019-7D40FF93FC9F}"/>
               </a:ext>
             </a:extLst>
           </p:cNvPr>
@@ -2731,7 +2731,7 @@
         <p:cNvPr id="1" name="Shape 505">
           <a:extLst>
             <a:ext uri="{FF2B5EF4-FFF2-40B4-BE49-F238E27FC236}">
-              <a16:creationId xmlns:a16="http://schemas.microsoft.com/office/drawing/2014/main" xmlns="" id="{68B89A22-7252-9D3E-55DF-11950A57FFC2}"/>
+              <a16:creationId xmlns="" xmlns:a16="http://schemas.microsoft.com/office/drawing/2014/main" id="{68B89A22-7252-9D3E-55DF-11950A57FFC2}"/>
             </a:ext>
           </a:extLst>
         </p:cNvPr>
@@ -2751,7 +2751,7 @@
           <p:cNvPr id="506" name="Google Shape;506;g1ec3e76e843_0_431:notes">
             <a:extLst>
               <a:ext uri="{FF2B5EF4-FFF2-40B4-BE49-F238E27FC236}">
-                <a16:creationId xmlns:a16="http://schemas.microsoft.com/office/drawing/2014/main" xmlns="" id="{446C6FAF-FEA0-FF3A-32BF-B5973FCA4D67}"/>
+                <a16:creationId xmlns="" xmlns:a16="http://schemas.microsoft.com/office/drawing/2014/main" id="{446C6FAF-FEA0-FF3A-32BF-B5973FCA4D67}"/>
               </a:ext>
             </a:extLst>
           </p:cNvPr>
@@ -2798,7 +2798,7 @@
           <p:cNvPr id="507" name="Google Shape;507;g1ec3e76e843_0_431:notes">
             <a:extLst>
               <a:ext uri="{FF2B5EF4-FFF2-40B4-BE49-F238E27FC236}">
-                <a16:creationId xmlns:a16="http://schemas.microsoft.com/office/drawing/2014/main" xmlns="" id="{3716BF81-477D-0AF8-9019-7D40FF93FC9F}"/>
+                <a16:creationId xmlns="" xmlns:a16="http://schemas.microsoft.com/office/drawing/2014/main" id="{3716BF81-477D-0AF8-9019-7D40FF93FC9F}"/>
               </a:ext>
             </a:extLst>
           </p:cNvPr>
@@ -2858,7 +2858,7 @@
         <p:cNvPr id="1" name="Shape 505">
           <a:extLst>
             <a:ext uri="{FF2B5EF4-FFF2-40B4-BE49-F238E27FC236}">
-              <a16:creationId xmlns:a16="http://schemas.microsoft.com/office/drawing/2014/main" xmlns="" id="{68B89A22-7252-9D3E-55DF-11950A57FFC2}"/>
+              <a16:creationId xmlns="" xmlns:a16="http://schemas.microsoft.com/office/drawing/2014/main" id="{68B89A22-7252-9D3E-55DF-11950A57FFC2}"/>
             </a:ext>
           </a:extLst>
         </p:cNvPr>
@@ -2878,7 +2878,7 @@
           <p:cNvPr id="506" name="Google Shape;506;g1ec3e76e843_0_431:notes">
             <a:extLst>
               <a:ext uri="{FF2B5EF4-FFF2-40B4-BE49-F238E27FC236}">
-                <a16:creationId xmlns:a16="http://schemas.microsoft.com/office/drawing/2014/main" xmlns="" id="{446C6FAF-FEA0-FF3A-32BF-B5973FCA4D67}"/>
+                <a16:creationId xmlns="" xmlns:a16="http://schemas.microsoft.com/office/drawing/2014/main" id="{446C6FAF-FEA0-FF3A-32BF-B5973FCA4D67}"/>
               </a:ext>
             </a:extLst>
           </p:cNvPr>
@@ -2925,7 +2925,7 @@
           <p:cNvPr id="507" name="Google Shape;507;g1ec3e76e843_0_431:notes">
             <a:extLst>
               <a:ext uri="{FF2B5EF4-FFF2-40B4-BE49-F238E27FC236}">
-                <a16:creationId xmlns:a16="http://schemas.microsoft.com/office/drawing/2014/main" xmlns="" id="{3716BF81-477D-0AF8-9019-7D40FF93FC9F}"/>
+                <a16:creationId xmlns="" xmlns:a16="http://schemas.microsoft.com/office/drawing/2014/main" id="{3716BF81-477D-0AF8-9019-7D40FF93FC9F}"/>
               </a:ext>
             </a:extLst>
           </p:cNvPr>
@@ -3312,7 +3312,7 @@
         <p:cNvPr id="1" name="Shape 519">
           <a:extLst>
             <a:ext uri="{FF2B5EF4-FFF2-40B4-BE49-F238E27FC236}">
-              <a16:creationId xmlns:a16="http://schemas.microsoft.com/office/drawing/2014/main" xmlns="" id="{BCBC297A-EC5F-F19E-6F0D-9414BCD07F4E}"/>
+              <a16:creationId xmlns="" xmlns:a16="http://schemas.microsoft.com/office/drawing/2014/main" id="{BCBC297A-EC5F-F19E-6F0D-9414BCD07F4E}"/>
             </a:ext>
           </a:extLst>
         </p:cNvPr>
@@ -3332,7 +3332,7 @@
           <p:cNvPr id="520" name="Google Shape;520;g1ec3e76e843_0_436:notes">
             <a:extLst>
               <a:ext uri="{FF2B5EF4-FFF2-40B4-BE49-F238E27FC236}">
-                <a16:creationId xmlns:a16="http://schemas.microsoft.com/office/drawing/2014/main" xmlns="" id="{C15A8C64-FC89-4617-4FC8-6F6AF6938A2A}"/>
+                <a16:creationId xmlns="" xmlns:a16="http://schemas.microsoft.com/office/drawing/2014/main" id="{C15A8C64-FC89-4617-4FC8-6F6AF6938A2A}"/>
               </a:ext>
             </a:extLst>
           </p:cNvPr>
@@ -3379,7 +3379,7 @@
           <p:cNvPr id="521" name="Google Shape;521;g1ec3e76e843_0_436:notes">
             <a:extLst>
               <a:ext uri="{FF2B5EF4-FFF2-40B4-BE49-F238E27FC236}">
-                <a16:creationId xmlns:a16="http://schemas.microsoft.com/office/drawing/2014/main" xmlns="" id="{3F74CD39-F352-8083-BDB6-1C0E5D89AF24}"/>
+                <a16:creationId xmlns="" xmlns:a16="http://schemas.microsoft.com/office/drawing/2014/main" id="{3F74CD39-F352-8083-BDB6-1C0E5D89AF24}"/>
               </a:ext>
             </a:extLst>
           </p:cNvPr>
@@ -3548,7 +3548,7 @@
         <p:cNvPr id="1" name="Shape 505">
           <a:extLst>
             <a:ext uri="{FF2B5EF4-FFF2-40B4-BE49-F238E27FC236}">
-              <a16:creationId xmlns:a16="http://schemas.microsoft.com/office/drawing/2014/main" xmlns="" id="{68B89A22-7252-9D3E-55DF-11950A57FFC2}"/>
+              <a16:creationId xmlns="" xmlns:a16="http://schemas.microsoft.com/office/drawing/2014/main" id="{68B89A22-7252-9D3E-55DF-11950A57FFC2}"/>
             </a:ext>
           </a:extLst>
         </p:cNvPr>
@@ -3568,7 +3568,7 @@
           <p:cNvPr id="506" name="Google Shape;506;g1ec3e76e843_0_431:notes">
             <a:extLst>
               <a:ext uri="{FF2B5EF4-FFF2-40B4-BE49-F238E27FC236}">
-                <a16:creationId xmlns:a16="http://schemas.microsoft.com/office/drawing/2014/main" xmlns="" id="{446C6FAF-FEA0-FF3A-32BF-B5973FCA4D67}"/>
+                <a16:creationId xmlns="" xmlns:a16="http://schemas.microsoft.com/office/drawing/2014/main" id="{446C6FAF-FEA0-FF3A-32BF-B5973FCA4D67}"/>
               </a:ext>
             </a:extLst>
           </p:cNvPr>
@@ -3615,7 +3615,7 @@
           <p:cNvPr id="507" name="Google Shape;507;g1ec3e76e843_0_431:notes">
             <a:extLst>
               <a:ext uri="{FF2B5EF4-FFF2-40B4-BE49-F238E27FC236}">
-                <a16:creationId xmlns:a16="http://schemas.microsoft.com/office/drawing/2014/main" xmlns="" id="{3716BF81-477D-0AF8-9019-7D40FF93FC9F}"/>
+                <a16:creationId xmlns="" xmlns:a16="http://schemas.microsoft.com/office/drawing/2014/main" id="{3716BF81-477D-0AF8-9019-7D40FF93FC9F}"/>
               </a:ext>
             </a:extLst>
           </p:cNvPr>
@@ -13030,7 +13030,7 @@
           <p:cNvPr id="3" name="Google Shape;524;p48">
             <a:extLst>
               <a:ext uri="{FF2B5EF4-FFF2-40B4-BE49-F238E27FC236}">
-                <a16:creationId xmlns:a16="http://schemas.microsoft.com/office/drawing/2014/main" xmlns="" id="{757BF2DF-D005-2CD2-72BF-45D822D3CB69}"/>
+                <a16:creationId xmlns="" xmlns:a16="http://schemas.microsoft.com/office/drawing/2014/main" id="{757BF2DF-D005-2CD2-72BF-45D822D3CB69}"/>
               </a:ext>
             </a:extLst>
           </p:cNvPr>
@@ -13413,7 +13413,7 @@
         <p:cNvPr id="1" name="Shape 508">
           <a:extLst>
             <a:ext uri="{FF2B5EF4-FFF2-40B4-BE49-F238E27FC236}">
-              <a16:creationId xmlns:a16="http://schemas.microsoft.com/office/drawing/2014/main" xmlns="" id="{44B24437-0E2C-B1BF-18A2-231EEF8E5B15}"/>
+              <a16:creationId xmlns="" xmlns:a16="http://schemas.microsoft.com/office/drawing/2014/main" id="{44B24437-0E2C-B1BF-18A2-231EEF8E5B15}"/>
             </a:ext>
           </a:extLst>
         </p:cNvPr>
@@ -13433,7 +13433,7 @@
           <p:cNvPr id="509" name="Google Shape;509;p47">
             <a:extLst>
               <a:ext uri="{FF2B5EF4-FFF2-40B4-BE49-F238E27FC236}">
-                <a16:creationId xmlns:a16="http://schemas.microsoft.com/office/drawing/2014/main" xmlns="" id="{261FC84A-5189-CB51-E761-1BD6225947E6}"/>
+                <a16:creationId xmlns="" xmlns:a16="http://schemas.microsoft.com/office/drawing/2014/main" id="{261FC84A-5189-CB51-E761-1BD6225947E6}"/>
               </a:ext>
             </a:extLst>
           </p:cNvPr>
@@ -13474,7 +13474,7 @@
           <p:cNvPr id="5" name="Google Shape;509;p47">
             <a:extLst>
               <a:ext uri="{FF2B5EF4-FFF2-40B4-BE49-F238E27FC236}">
-                <a16:creationId xmlns:a16="http://schemas.microsoft.com/office/drawing/2014/main" xmlns="" id="{D9DB8719-0991-2E66-D15D-C4DFC228786E}"/>
+                <a16:creationId xmlns="" xmlns:a16="http://schemas.microsoft.com/office/drawing/2014/main" id="{D9DB8719-0991-2E66-D15D-C4DFC228786E}"/>
               </a:ext>
             </a:extLst>
           </p:cNvPr>
@@ -13763,7 +13763,7 @@
           <p:cNvPr id="3" name="Рисунок 2">
             <a:extLst>
               <a:ext uri="{FF2B5EF4-FFF2-40B4-BE49-F238E27FC236}">
-                <a16:creationId xmlns:a16="http://schemas.microsoft.com/office/drawing/2014/main" xmlns="" id="{6485D845-DF70-0C3D-B60C-DCFC937D5EF9}"/>
+                <a16:creationId xmlns="" xmlns:a16="http://schemas.microsoft.com/office/drawing/2014/main" id="{6485D845-DF70-0C3D-B60C-DCFC937D5EF9}"/>
               </a:ext>
             </a:extLst>
           </p:cNvPr>
@@ -13793,7 +13793,7 @@
           <p:cNvPr id="7" name="Рисунок 6">
             <a:extLst>
               <a:ext uri="{FF2B5EF4-FFF2-40B4-BE49-F238E27FC236}">
-                <a16:creationId xmlns:a16="http://schemas.microsoft.com/office/drawing/2014/main" xmlns="" id="{76E595DB-DF5B-ED87-D77C-C2961E0276F8}"/>
+                <a16:creationId xmlns="" xmlns:a16="http://schemas.microsoft.com/office/drawing/2014/main" id="{76E595DB-DF5B-ED87-D77C-C2961E0276F8}"/>
               </a:ext>
             </a:extLst>
           </p:cNvPr>
@@ -13853,7 +13853,7 @@
           <p:cNvPr id="3" name="Google Shape;509;p47">
             <a:extLst>
               <a:ext uri="{FF2B5EF4-FFF2-40B4-BE49-F238E27FC236}">
-                <a16:creationId xmlns:a16="http://schemas.microsoft.com/office/drawing/2014/main" xmlns="" id="{261FC84A-5189-CB51-E761-1BD6225947E6}"/>
+                <a16:creationId xmlns="" xmlns:a16="http://schemas.microsoft.com/office/drawing/2014/main" id="{261FC84A-5189-CB51-E761-1BD6225947E6}"/>
               </a:ext>
             </a:extLst>
           </p:cNvPr>
@@ -13905,7 +13905,7 @@
           <p:cNvPr id="5" name="Рисунок 4">
             <a:extLst>
               <a:ext uri="{FF2B5EF4-FFF2-40B4-BE49-F238E27FC236}">
-                <a16:creationId xmlns:a16="http://schemas.microsoft.com/office/drawing/2014/main" xmlns="" id="{E66EE6BB-996F-FA43-4837-A6B998584782}"/>
+                <a16:creationId xmlns="" xmlns:a16="http://schemas.microsoft.com/office/drawing/2014/main" id="{E66EE6BB-996F-FA43-4837-A6B998584782}"/>
               </a:ext>
             </a:extLst>
           </p:cNvPr>
@@ -14517,7 +14517,7 @@
         <p:cNvPr id="1" name="Shape 508">
           <a:extLst>
             <a:ext uri="{FF2B5EF4-FFF2-40B4-BE49-F238E27FC236}">
-              <a16:creationId xmlns:a16="http://schemas.microsoft.com/office/drawing/2014/main" xmlns="" id="{44B24437-0E2C-B1BF-18A2-231EEF8E5B15}"/>
+              <a16:creationId xmlns="" xmlns:a16="http://schemas.microsoft.com/office/drawing/2014/main" id="{44B24437-0E2C-B1BF-18A2-231EEF8E5B15}"/>
             </a:ext>
           </a:extLst>
         </p:cNvPr>
@@ -14537,7 +14537,7 @@
           <p:cNvPr id="509" name="Google Shape;509;p47">
             <a:extLst>
               <a:ext uri="{FF2B5EF4-FFF2-40B4-BE49-F238E27FC236}">
-                <a16:creationId xmlns:a16="http://schemas.microsoft.com/office/drawing/2014/main" xmlns="" id="{261FC84A-5189-CB51-E761-1BD6225947E6}"/>
+                <a16:creationId xmlns="" xmlns:a16="http://schemas.microsoft.com/office/drawing/2014/main" id="{261FC84A-5189-CB51-E761-1BD6225947E6}"/>
               </a:ext>
             </a:extLst>
           </p:cNvPr>
@@ -14578,7 +14578,7 @@
           <p:cNvPr id="5" name="Google Shape;509;p47">
             <a:extLst>
               <a:ext uri="{FF2B5EF4-FFF2-40B4-BE49-F238E27FC236}">
-                <a16:creationId xmlns:a16="http://schemas.microsoft.com/office/drawing/2014/main" xmlns="" id="{D9DB8719-0991-2E66-D15D-C4DFC228786E}"/>
+                <a16:creationId xmlns="" xmlns:a16="http://schemas.microsoft.com/office/drawing/2014/main" id="{D9DB8719-0991-2E66-D15D-C4DFC228786E}"/>
               </a:ext>
             </a:extLst>
           </p:cNvPr>
@@ -14867,7 +14867,7 @@
           <p:cNvPr id="3" name="Рисунок 2">
             <a:extLst>
               <a:ext uri="{FF2B5EF4-FFF2-40B4-BE49-F238E27FC236}">
-                <a16:creationId xmlns:a16="http://schemas.microsoft.com/office/drawing/2014/main" xmlns="" id="{F9F5F3DF-7781-180D-D71B-2772BDED0F55}"/>
+                <a16:creationId xmlns="" xmlns:a16="http://schemas.microsoft.com/office/drawing/2014/main" id="{F9F5F3DF-7781-180D-D71B-2772BDED0F55}"/>
               </a:ext>
             </a:extLst>
           </p:cNvPr>
@@ -14897,7 +14897,7 @@
           <p:cNvPr id="8" name="Рисунок 7">
             <a:extLst>
               <a:ext uri="{FF2B5EF4-FFF2-40B4-BE49-F238E27FC236}">
-                <a16:creationId xmlns:a16="http://schemas.microsoft.com/office/drawing/2014/main" xmlns="" id="{4C506C0A-004E-C9C2-7301-90AD6F5AA35F}"/>
+                <a16:creationId xmlns="" xmlns:a16="http://schemas.microsoft.com/office/drawing/2014/main" id="{4C506C0A-004E-C9C2-7301-90AD6F5AA35F}"/>
               </a:ext>
             </a:extLst>
           </p:cNvPr>
@@ -14957,7 +14957,7 @@
           <p:cNvPr id="3" name="Google Shape;509;p47">
             <a:extLst>
               <a:ext uri="{FF2B5EF4-FFF2-40B4-BE49-F238E27FC236}">
-                <a16:creationId xmlns:a16="http://schemas.microsoft.com/office/drawing/2014/main" xmlns="" id="{261FC84A-5189-CB51-E761-1BD6225947E6}"/>
+                <a16:creationId xmlns="" xmlns:a16="http://schemas.microsoft.com/office/drawing/2014/main" id="{261FC84A-5189-CB51-E761-1BD6225947E6}"/>
               </a:ext>
             </a:extLst>
           </p:cNvPr>
@@ -15210,7 +15210,7 @@
         <p:cNvPr id="1" name="Shape 508">
           <a:extLst>
             <a:ext uri="{FF2B5EF4-FFF2-40B4-BE49-F238E27FC236}">
-              <a16:creationId xmlns:a16="http://schemas.microsoft.com/office/drawing/2014/main" xmlns="" id="{44B24437-0E2C-B1BF-18A2-231EEF8E5B15}"/>
+              <a16:creationId xmlns="" xmlns:a16="http://schemas.microsoft.com/office/drawing/2014/main" id="{44B24437-0E2C-B1BF-18A2-231EEF8E5B15}"/>
             </a:ext>
           </a:extLst>
         </p:cNvPr>
@@ -15580,13 +15580,7 @@
               <a:rPr lang="ru-RU" sz="2000" dirty="0" smtClean="0">
                 <a:latin typeface="Maven Pro" panose="00000500000000000000" pitchFamily="2" charset="0"/>
               </a:rPr>
-              <a:t> слоёв </a:t>
-            </a:r>
-            <a:r>
-              <a:rPr lang="ru-RU" sz="2000" dirty="0" smtClean="0">
-                <a:latin typeface="Maven Pro" panose="00000500000000000000" pitchFamily="2" charset="0"/>
-              </a:rPr>
-              <a:t>в 8</a:t>
+              <a:t> слоёв в 8</a:t>
             </a:r>
             <a:r>
               <a:rPr lang="en-US" sz="2000" dirty="0" smtClean="0">
@@ -15751,12 +15745,10 @@
           <a:p>
             <a:pPr algn="ctr"/>
             <a:r>
-              <a:rPr lang="ru-RU" dirty="0" err="1" smtClean="0"/>
-              <a:t>Инференс</a:t>
-            </a:r>
-            <a:r>
-              <a:rPr lang="ru-RU" dirty="0" smtClean="0"/>
-              <a:t> с </a:t>
+              <a:rPr lang="en-US" dirty="0" smtClean="0">
+                <a:latin typeface="Maven Pro Medium" panose="00000600000000000000" pitchFamily="2" charset="0"/>
+              </a:rPr>
+              <a:t>Inference c </a:t>
             </a:r>
             <a:r>
               <a:rPr lang="en-US" dirty="0" smtClean="0">
@@ -15765,22 +15757,16 @@
               <a:t>F.conv2</a:t>
             </a:r>
             <a:r>
-              <a:rPr lang="ru-RU" dirty="0">
+              <a:rPr lang="ru-RU" dirty="0" smtClean="0">
                 <a:latin typeface="Maven Pro Medium" panose="00000600000000000000" pitchFamily="2" charset="0"/>
               </a:rPr>
               <a:t> </a:t>
             </a:r>
             <a:r>
-              <a:rPr lang="ru-RU" dirty="0" smtClean="0">
-                <a:latin typeface="Maven Pro Medium" panose="00000600000000000000" pitchFamily="2" charset="0"/>
-              </a:rPr>
-              <a:t>в </a:t>
-            </a:r>
-            <a:r>
               <a:rPr lang="en-US" dirty="0" smtClean="0">
                 <a:latin typeface="Maven Pro Medium" panose="00000600000000000000" pitchFamily="2" charset="0"/>
               </a:rPr>
-              <a:t>fp16</a:t>
+              <a:t>(fp16)</a:t>
             </a:r>
             <a:endParaRPr lang="ru-RU" dirty="0"/>
           </a:p>
@@ -16324,24 +16310,44 @@
           <a:p>
             <a:pPr algn="ctr"/>
             <a:r>
-              <a:rPr lang="ru-RU" dirty="0" err="1"/>
-              <a:t>Инференс</a:t>
-            </a:r>
-            <a:r>
-              <a:rPr lang="ru-RU" dirty="0"/>
-              <a:t> с </a:t>
-            </a:r>
-            <a:r>
-              <a:rPr lang="en-US" dirty="0"/>
+              <a:rPr lang="en-US" dirty="0">
+                <a:latin typeface="Maven Pro Medium" panose="00000600000000000000" pitchFamily="2" charset="0"/>
+              </a:rPr>
+              <a:t>Inference </a:t>
+            </a:r>
+            <a:r>
+              <a:rPr lang="en-US" dirty="0" smtClean="0">
+                <a:latin typeface="Maven Pro Medium" panose="00000600000000000000" pitchFamily="2" charset="0"/>
+              </a:rPr>
               <a:t>Triton-</a:t>
             </a:r>
             <a:r>
-              <a:rPr lang="ru-RU" dirty="0"/>
-              <a:t>ядром в </a:t>
-            </a:r>
-            <a:r>
-              <a:rPr lang="en-US" dirty="0"/>
-              <a:t>int8</a:t>
+              <a:rPr lang="en-US" dirty="0">
+                <a:latin typeface="Maven Pro Medium" panose="00000600000000000000" pitchFamily="2" charset="0"/>
+              </a:rPr>
+              <a:t>k</a:t>
+            </a:r>
+            <a:r>
+              <a:rPr lang="en-US" dirty="0" smtClean="0">
+                <a:latin typeface="Maven Pro Medium" panose="00000600000000000000" pitchFamily="2" charset="0"/>
+              </a:rPr>
+              <a:t>ernel</a:t>
+            </a:r>
+            <a:r>
+              <a:rPr lang="ru-RU" dirty="0" smtClean="0"/>
+              <a:t> </a:t>
+            </a:r>
+            <a:r>
+              <a:rPr lang="en-US" dirty="0">
+                <a:latin typeface="Maven Pro Medium" panose="00000600000000000000" pitchFamily="2" charset="0"/>
+              </a:rPr>
+              <a:t>(</a:t>
+            </a:r>
+            <a:r>
+              <a:rPr lang="en-US" dirty="0" smtClean="0">
+                <a:latin typeface="Maven Pro Medium" panose="00000600000000000000" pitchFamily="2" charset="0"/>
+              </a:rPr>
+              <a:t>int8)</a:t>
             </a:r>
             <a:endParaRPr lang="ru-RU" dirty="0"/>
           </a:p>
@@ -16398,7 +16404,7 @@
         <p:cNvPr id="1" name="Shape 508">
           <a:extLst>
             <a:ext uri="{FF2B5EF4-FFF2-40B4-BE49-F238E27FC236}">
-              <a16:creationId xmlns:a16="http://schemas.microsoft.com/office/drawing/2014/main" xmlns="" id="{44B24437-0E2C-B1BF-18A2-231EEF8E5B15}"/>
+              <a16:creationId xmlns="" xmlns:a16="http://schemas.microsoft.com/office/drawing/2014/main" id="{44B24437-0E2C-B1BF-18A2-231EEF8E5B15}"/>
             </a:ext>
           </a:extLst>
         </p:cNvPr>
@@ -16418,7 +16424,7 @@
           <p:cNvPr id="509" name="Google Shape;509;p47">
             <a:extLst>
               <a:ext uri="{FF2B5EF4-FFF2-40B4-BE49-F238E27FC236}">
-                <a16:creationId xmlns:a16="http://schemas.microsoft.com/office/drawing/2014/main" xmlns="" id="{261FC84A-5189-CB51-E761-1BD6225947E6}"/>
+                <a16:creationId xmlns="" xmlns:a16="http://schemas.microsoft.com/office/drawing/2014/main" id="{261FC84A-5189-CB51-E761-1BD6225947E6}"/>
               </a:ext>
             </a:extLst>
           </p:cNvPr>
@@ -16459,7 +16465,7 @@
           <p:cNvPr id="5" name="Google Shape;509;p47">
             <a:extLst>
               <a:ext uri="{FF2B5EF4-FFF2-40B4-BE49-F238E27FC236}">
-                <a16:creationId xmlns:a16="http://schemas.microsoft.com/office/drawing/2014/main" xmlns="" id="{D9DB8719-0991-2E66-D15D-C4DFC228786E}"/>
+                <a16:creationId xmlns="" xmlns:a16="http://schemas.microsoft.com/office/drawing/2014/main" id="{D9DB8719-0991-2E66-D15D-C4DFC228786E}"/>
               </a:ext>
             </a:extLst>
           </p:cNvPr>
@@ -16838,7 +16844,7 @@
           <p:cNvPr id="3" name="Google Shape;509;p47">
             <a:extLst>
               <a:ext uri="{FF2B5EF4-FFF2-40B4-BE49-F238E27FC236}">
-                <a16:creationId xmlns:a16="http://schemas.microsoft.com/office/drawing/2014/main" xmlns="" id="{261FC84A-5189-CB51-E761-1BD6225947E6}"/>
+                <a16:creationId xmlns="" xmlns:a16="http://schemas.microsoft.com/office/drawing/2014/main" id="{261FC84A-5189-CB51-E761-1BD6225947E6}"/>
               </a:ext>
             </a:extLst>
           </p:cNvPr>
@@ -16910,7 +16916,7 @@
           <p:cNvPr id="4" name="Рисунок 3">
             <a:extLst>
               <a:ext uri="{FF2B5EF4-FFF2-40B4-BE49-F238E27FC236}">
-                <a16:creationId xmlns:a16="http://schemas.microsoft.com/office/drawing/2014/main" xmlns="" id="{B78FF8A2-6B28-852D-FDFC-9942AB1BBBE1}"/>
+                <a16:creationId xmlns="" xmlns:a16="http://schemas.microsoft.com/office/drawing/2014/main" id="{B78FF8A2-6B28-852D-FDFC-9942AB1BBBE1}"/>
               </a:ext>
             </a:extLst>
           </p:cNvPr>
@@ -17164,7 +17170,7 @@
         <p:cNvPr id="1" name="Shape 508">
           <a:extLst>
             <a:ext uri="{FF2B5EF4-FFF2-40B4-BE49-F238E27FC236}">
-              <a16:creationId xmlns:a16="http://schemas.microsoft.com/office/drawing/2014/main" xmlns="" id="{44B24437-0E2C-B1BF-18A2-231EEF8E5B15}"/>
+              <a16:creationId xmlns="" xmlns:a16="http://schemas.microsoft.com/office/drawing/2014/main" id="{44B24437-0E2C-B1BF-18A2-231EEF8E5B15}"/>
             </a:ext>
           </a:extLst>
         </p:cNvPr>
@@ -17673,7 +17679,7 @@
         <p:cNvPr id="1" name="Shape 508">
           <a:extLst>
             <a:ext uri="{FF2B5EF4-FFF2-40B4-BE49-F238E27FC236}">
-              <a16:creationId xmlns:a16="http://schemas.microsoft.com/office/drawing/2014/main" xmlns="" id="{44B24437-0E2C-B1BF-18A2-231EEF8E5B15}"/>
+              <a16:creationId xmlns="" xmlns:a16="http://schemas.microsoft.com/office/drawing/2014/main" id="{44B24437-0E2C-B1BF-18A2-231EEF8E5B15}"/>
             </a:ext>
           </a:extLst>
         </p:cNvPr>
@@ -17693,7 +17699,7 @@
           <p:cNvPr id="509" name="Google Shape;509;p47">
             <a:extLst>
               <a:ext uri="{FF2B5EF4-FFF2-40B4-BE49-F238E27FC236}">
-                <a16:creationId xmlns:a16="http://schemas.microsoft.com/office/drawing/2014/main" xmlns="" id="{261FC84A-5189-CB51-E761-1BD6225947E6}"/>
+                <a16:creationId xmlns="" xmlns:a16="http://schemas.microsoft.com/office/drawing/2014/main" id="{261FC84A-5189-CB51-E761-1BD6225947E6}"/>
               </a:ext>
             </a:extLst>
           </p:cNvPr>
@@ -17774,7 +17780,7 @@
         <p:cNvPr id="1" name="Shape 508">
           <a:extLst>
             <a:ext uri="{FF2B5EF4-FFF2-40B4-BE49-F238E27FC236}">
-              <a16:creationId xmlns:a16="http://schemas.microsoft.com/office/drawing/2014/main" xmlns="" id="{44B24437-0E2C-B1BF-18A2-231EEF8E5B15}"/>
+              <a16:creationId xmlns="" xmlns:a16="http://schemas.microsoft.com/office/drawing/2014/main" id="{44B24437-0E2C-B1BF-18A2-231EEF8E5B15}"/>
             </a:ext>
           </a:extLst>
         </p:cNvPr>
@@ -17794,7 +17800,7 @@
           <p:cNvPr id="5" name="Google Shape;509;p47">
             <a:extLst>
               <a:ext uri="{FF2B5EF4-FFF2-40B4-BE49-F238E27FC236}">
-                <a16:creationId xmlns:a16="http://schemas.microsoft.com/office/drawing/2014/main" xmlns="" id="{D9DB8719-0991-2E66-D15D-C4DFC228786E}"/>
+                <a16:creationId xmlns="" xmlns:a16="http://schemas.microsoft.com/office/drawing/2014/main" id="{D9DB8719-0991-2E66-D15D-C4DFC228786E}"/>
               </a:ext>
             </a:extLst>
           </p:cNvPr>
@@ -18848,7 +18854,7 @@
         <p:cNvPr id="1" name="Shape 508">
           <a:extLst>
             <a:ext uri="{FF2B5EF4-FFF2-40B4-BE49-F238E27FC236}">
-              <a16:creationId xmlns:a16="http://schemas.microsoft.com/office/drawing/2014/main" xmlns="" id="{44B24437-0E2C-B1BF-18A2-231EEF8E5B15}"/>
+              <a16:creationId xmlns="" xmlns:a16="http://schemas.microsoft.com/office/drawing/2014/main" id="{44B24437-0E2C-B1BF-18A2-231EEF8E5B15}"/>
             </a:ext>
           </a:extLst>
         </p:cNvPr>
@@ -18868,7 +18874,7 @@
           <p:cNvPr id="5" name="Google Shape;509;p47">
             <a:extLst>
               <a:ext uri="{FF2B5EF4-FFF2-40B4-BE49-F238E27FC236}">
-                <a16:creationId xmlns:a16="http://schemas.microsoft.com/office/drawing/2014/main" xmlns="" id="{D9DB8719-0991-2E66-D15D-C4DFC228786E}"/>
+                <a16:creationId xmlns="" xmlns:a16="http://schemas.microsoft.com/office/drawing/2014/main" id="{D9DB8719-0991-2E66-D15D-C4DFC228786E}"/>
               </a:ext>
             </a:extLst>
           </p:cNvPr>
@@ -19461,7 +19467,7 @@
         <p:cNvPr id="1" name="Shape 508">
           <a:extLst>
             <a:ext uri="{FF2B5EF4-FFF2-40B4-BE49-F238E27FC236}">
-              <a16:creationId xmlns:a16="http://schemas.microsoft.com/office/drawing/2014/main" xmlns="" id="{44B24437-0E2C-B1BF-18A2-231EEF8E5B15}"/>
+              <a16:creationId xmlns="" xmlns:a16="http://schemas.microsoft.com/office/drawing/2014/main" id="{44B24437-0E2C-B1BF-18A2-231EEF8E5B15}"/>
             </a:ext>
           </a:extLst>
         </p:cNvPr>
@@ -19481,7 +19487,7 @@
           <p:cNvPr id="5" name="Google Shape;509;p47">
             <a:extLst>
               <a:ext uri="{FF2B5EF4-FFF2-40B4-BE49-F238E27FC236}">
-                <a16:creationId xmlns:a16="http://schemas.microsoft.com/office/drawing/2014/main" xmlns="" id="{D9DB8719-0991-2E66-D15D-C4DFC228786E}"/>
+                <a16:creationId xmlns="" xmlns:a16="http://schemas.microsoft.com/office/drawing/2014/main" id="{D9DB8719-0991-2E66-D15D-C4DFC228786E}"/>
               </a:ext>
             </a:extLst>
           </p:cNvPr>
@@ -20253,7 +20259,7 @@
         <p:cNvPr id="1" name="Shape 508">
           <a:extLst>
             <a:ext uri="{FF2B5EF4-FFF2-40B4-BE49-F238E27FC236}">
-              <a16:creationId xmlns:a16="http://schemas.microsoft.com/office/drawing/2014/main" xmlns="" id="{44B24437-0E2C-B1BF-18A2-231EEF8E5B15}"/>
+              <a16:creationId xmlns="" xmlns:a16="http://schemas.microsoft.com/office/drawing/2014/main" id="{44B24437-0E2C-B1BF-18A2-231EEF8E5B15}"/>
             </a:ext>
           </a:extLst>
         </p:cNvPr>
@@ -20273,7 +20279,7 @@
           <p:cNvPr id="509" name="Google Shape;509;p47">
             <a:extLst>
               <a:ext uri="{FF2B5EF4-FFF2-40B4-BE49-F238E27FC236}">
-                <a16:creationId xmlns:a16="http://schemas.microsoft.com/office/drawing/2014/main" xmlns="" id="{261FC84A-5189-CB51-E761-1BD6225947E6}"/>
+                <a16:creationId xmlns="" xmlns:a16="http://schemas.microsoft.com/office/drawing/2014/main" id="{261FC84A-5189-CB51-E761-1BD6225947E6}"/>
               </a:ext>
             </a:extLst>
           </p:cNvPr>
@@ -20314,7 +20320,7 @@
           <p:cNvPr id="5" name="Google Shape;509;p47">
             <a:extLst>
               <a:ext uri="{FF2B5EF4-FFF2-40B4-BE49-F238E27FC236}">
-                <a16:creationId xmlns:a16="http://schemas.microsoft.com/office/drawing/2014/main" xmlns="" id="{D9DB8719-0991-2E66-D15D-C4DFC228786E}"/>
+                <a16:creationId xmlns="" xmlns:a16="http://schemas.microsoft.com/office/drawing/2014/main" id="{D9DB8719-0991-2E66-D15D-C4DFC228786E}"/>
               </a:ext>
             </a:extLst>
           </p:cNvPr>
@@ -20603,7 +20609,7 @@
           <p:cNvPr id="2" name="Рисунок 1">
             <a:extLst>
               <a:ext uri="{FF2B5EF4-FFF2-40B4-BE49-F238E27FC236}">
-                <a16:creationId xmlns:a16="http://schemas.microsoft.com/office/drawing/2014/main" xmlns="" id="{412CCA63-DAD6-5187-D58F-B6AF645FCE45}"/>
+                <a16:creationId xmlns="" xmlns:a16="http://schemas.microsoft.com/office/drawing/2014/main" id="{412CCA63-DAD6-5187-D58F-B6AF645FCE45}"/>
               </a:ext>
             </a:extLst>
           </p:cNvPr>
@@ -20633,7 +20639,7 @@
           <p:cNvPr id="8" name="Рисунок 7">
             <a:extLst>
               <a:ext uri="{FF2B5EF4-FFF2-40B4-BE49-F238E27FC236}">
-                <a16:creationId xmlns:a16="http://schemas.microsoft.com/office/drawing/2014/main" xmlns="" id="{B6A7511A-9ED8-17DE-0159-3CC7432786A0}"/>
+                <a16:creationId xmlns="" xmlns:a16="http://schemas.microsoft.com/office/drawing/2014/main" id="{B6A7511A-9ED8-17DE-0159-3CC7432786A0}"/>
               </a:ext>
             </a:extLst>
           </p:cNvPr>
@@ -20693,7 +20699,7 @@
           <p:cNvPr id="3" name="Google Shape;509;p47">
             <a:extLst>
               <a:ext uri="{FF2B5EF4-FFF2-40B4-BE49-F238E27FC236}">
-                <a16:creationId xmlns:a16="http://schemas.microsoft.com/office/drawing/2014/main" xmlns="" id="{261FC84A-5189-CB51-E761-1BD6225947E6}"/>
+                <a16:creationId xmlns="" xmlns:a16="http://schemas.microsoft.com/office/drawing/2014/main" id="{261FC84A-5189-CB51-E761-1BD6225947E6}"/>
               </a:ext>
             </a:extLst>
           </p:cNvPr>
@@ -20756,7 +20762,7 @@
           <p:cNvPr id="4" name="Рисунок 3">
             <a:extLst>
               <a:ext uri="{FF2B5EF4-FFF2-40B4-BE49-F238E27FC236}">
-                <a16:creationId xmlns:a16="http://schemas.microsoft.com/office/drawing/2014/main" xmlns="" id="{B78FF8A2-6B28-852D-FDFC-9942AB1BBBE1}"/>
+                <a16:creationId xmlns="" xmlns:a16="http://schemas.microsoft.com/office/drawing/2014/main" id="{B78FF8A2-6B28-852D-FDFC-9942AB1BBBE1}"/>
               </a:ext>
             </a:extLst>
           </p:cNvPr>
@@ -20786,7 +20792,7 @@
           <p:cNvPr id="6" name="Рисунок 5">
             <a:extLst>
               <a:ext uri="{FF2B5EF4-FFF2-40B4-BE49-F238E27FC236}">
-                <a16:creationId xmlns:a16="http://schemas.microsoft.com/office/drawing/2014/main" xmlns="" id="{DF6E47BE-B841-C4E1-48FF-DFB00526B322}"/>
+                <a16:creationId xmlns="" xmlns:a16="http://schemas.microsoft.com/office/drawing/2014/main" id="{DF6E47BE-B841-C4E1-48FF-DFB00526B322}"/>
               </a:ext>
             </a:extLst>
           </p:cNvPr>
@@ -21541,7 +21547,7 @@
         <p:cNvPr id="1" name="Shape 522">
           <a:extLst>
             <a:ext uri="{FF2B5EF4-FFF2-40B4-BE49-F238E27FC236}">
-              <a16:creationId xmlns:a16="http://schemas.microsoft.com/office/drawing/2014/main" xmlns="" id="{3E7405EA-13FA-F510-58E3-D7E1AD2BF1EE}"/>
+              <a16:creationId xmlns="" xmlns:a16="http://schemas.microsoft.com/office/drawing/2014/main" id="{3E7405EA-13FA-F510-58E3-D7E1AD2BF1EE}"/>
             </a:ext>
           </a:extLst>
         </p:cNvPr>
@@ -21561,7 +21567,7 @@
           <p:cNvPr id="523" name="Google Shape;523;p48">
             <a:extLst>
               <a:ext uri="{FF2B5EF4-FFF2-40B4-BE49-F238E27FC236}">
-                <a16:creationId xmlns:a16="http://schemas.microsoft.com/office/drawing/2014/main" xmlns="" id="{57229E31-C117-D41E-2496-8F5D0F8C6499}"/>
+                <a16:creationId xmlns="" xmlns:a16="http://schemas.microsoft.com/office/drawing/2014/main" id="{57229E31-C117-D41E-2496-8F5D0F8C6499}"/>
               </a:ext>
             </a:extLst>
           </p:cNvPr>
@@ -22085,7 +22091,7 @@
         <p:cNvPr id="1" name="Shape 508">
           <a:extLst>
             <a:ext uri="{FF2B5EF4-FFF2-40B4-BE49-F238E27FC236}">
-              <a16:creationId xmlns:a16="http://schemas.microsoft.com/office/drawing/2014/main" xmlns="" id="{44B24437-0E2C-B1BF-18A2-231EEF8E5B15}"/>
+              <a16:creationId xmlns="" xmlns:a16="http://schemas.microsoft.com/office/drawing/2014/main" id="{44B24437-0E2C-B1BF-18A2-231EEF8E5B15}"/>
             </a:ext>
           </a:extLst>
         </p:cNvPr>
@@ -22105,7 +22111,7 @@
           <p:cNvPr id="509" name="Google Shape;509;p47">
             <a:extLst>
               <a:ext uri="{FF2B5EF4-FFF2-40B4-BE49-F238E27FC236}">
-                <a16:creationId xmlns:a16="http://schemas.microsoft.com/office/drawing/2014/main" xmlns="" id="{261FC84A-5189-CB51-E761-1BD6225947E6}"/>
+                <a16:creationId xmlns="" xmlns:a16="http://schemas.microsoft.com/office/drawing/2014/main" id="{261FC84A-5189-CB51-E761-1BD6225947E6}"/>
               </a:ext>
             </a:extLst>
           </p:cNvPr>
@@ -22146,7 +22152,7 @@
           <p:cNvPr id="2" name="Рисунок 1" descr="Изображение выглядит как линия, График, диаграмма, снимок экрана&#10;&#10;Содержимое, созданное искусственным интеллектом, может быть неверным.">
             <a:extLst>
               <a:ext uri="{FF2B5EF4-FFF2-40B4-BE49-F238E27FC236}">
-                <a16:creationId xmlns:a16="http://schemas.microsoft.com/office/drawing/2014/main" xmlns="" id="{52DE384D-4F4D-6D41-2F27-0C2522E86B10}"/>
+                <a16:creationId xmlns="" xmlns:a16="http://schemas.microsoft.com/office/drawing/2014/main" id="{52DE384D-4F4D-6D41-2F27-0C2522E86B10}"/>
               </a:ext>
             </a:extLst>
           </p:cNvPr>
@@ -22176,7 +22182,7 @@
           <p:cNvPr id="3" name="Рисунок 2" descr="Изображение выглядит как текст, График, линия, диаграмма&#10;&#10;Содержимое, созданное искусственным интеллектом, может быть неверным.">
             <a:extLst>
               <a:ext uri="{FF2B5EF4-FFF2-40B4-BE49-F238E27FC236}">
-                <a16:creationId xmlns:a16="http://schemas.microsoft.com/office/drawing/2014/main" xmlns="" id="{82AC121C-7EE5-89AC-199F-DBF10D5A82BF}"/>
+                <a16:creationId xmlns="" xmlns:a16="http://schemas.microsoft.com/office/drawing/2014/main" id="{82AC121C-7EE5-89AC-199F-DBF10D5A82BF}"/>
               </a:ext>
             </a:extLst>
           </p:cNvPr>
@@ -22206,7 +22212,7 @@
           <p:cNvPr id="5" name="Google Shape;509;p47">
             <a:extLst>
               <a:ext uri="{FF2B5EF4-FFF2-40B4-BE49-F238E27FC236}">
-                <a16:creationId xmlns:a16="http://schemas.microsoft.com/office/drawing/2014/main" xmlns="" id="{D9DB8719-0991-2E66-D15D-C4DFC228786E}"/>
+                <a16:creationId xmlns="" xmlns:a16="http://schemas.microsoft.com/office/drawing/2014/main" id="{D9DB8719-0991-2E66-D15D-C4DFC228786E}"/>
               </a:ext>
             </a:extLst>
           </p:cNvPr>
@@ -22525,7 +22531,7 @@
           <p:cNvPr id="24" name="Рисунок 23" descr="Изображение выглядит как текст, человек, снимок экрана, одежда&#10;&#10;Содержимое, созданное искусственным интеллектом, может быть неверным.">
             <a:extLst>
               <a:ext uri="{FF2B5EF4-FFF2-40B4-BE49-F238E27FC236}">
-                <a16:creationId xmlns:a16="http://schemas.microsoft.com/office/drawing/2014/main" xmlns="" id="{65D54DA4-CBB4-A737-1C4B-D11A8853D738}"/>
+                <a16:creationId xmlns="" xmlns:a16="http://schemas.microsoft.com/office/drawing/2014/main" id="{65D54DA4-CBB4-A737-1C4B-D11A8853D738}"/>
               </a:ext>
             </a:extLst>
           </p:cNvPr>

</xml_diff>